<commit_message>
Typo in filename and new ppt
</commit_message>
<xml_diff>
--- a/docs/SpeciesViewer architecture pictures.pptx
+++ b/docs/SpeciesViewer architecture pictures.pptx
@@ -5,7 +5,7 @@
     <p:sldMasterId id="2147483648" r:id="rId1"/>
   </p:sldMasterIdLst>
   <p:notesMasterIdLst>
-    <p:notesMasterId r:id="rId9"/>
+    <p:notesMasterId r:id="rId11"/>
   </p:notesMasterIdLst>
   <p:sldIdLst>
     <p:sldId id="256" r:id="rId2"/>
@@ -15,6 +15,8 @@
     <p:sldId id="260" r:id="rId6"/>
     <p:sldId id="261" r:id="rId7"/>
     <p:sldId id="262" r:id="rId8"/>
+    <p:sldId id="263" r:id="rId9"/>
+    <p:sldId id="264" r:id="rId10"/>
   </p:sldIdLst>
   <p:sldSz cx="12192000" cy="6858000"/>
   <p:notesSz cx="6858000" cy="9144000"/>
@@ -113,6 +115,11 @@
       </a:defRPr>
     </a:lvl9pPr>
   </p:defaultTextStyle>
+  <p:extLst>
+    <p:ext uri="{EFAFB233-063F-42B5-8137-9DF3F51BA10A}">
+      <p15:sldGuideLst xmlns:p15="http://schemas.microsoft.com/office/powerpoint/2012/main"/>
+    </p:ext>
+  </p:extLst>
 </p:presentation>
 </file>
 
@@ -3755,7 +3762,7 @@
           <a:p>
             <a:fld id="{76D4F64B-0D6B-41C4-960F-8BF36568A172}" type="datetimeFigureOut">
               <a:rPr lang="nl-NL" smtClean="0"/>
-              <a:t>24-9-2024</a:t>
+              <a:t>4-10-2024</a:t>
             </a:fld>
             <a:endParaRPr lang="nl-NL"/>
           </a:p>
@@ -4567,6 +4574,90 @@
 </p:notes>
 </file>
 
+<file path=ppt/notesSlides/notesSlide3.xml><?xml version="1.0" encoding="utf-8"?>
+<p:notes xmlns:a="http://schemas.openxmlformats.org/drawingml/2006/main" xmlns:r="http://schemas.openxmlformats.org/officeDocument/2006/relationships" xmlns:p="http://schemas.openxmlformats.org/presentationml/2006/main">
+  <p:cSld>
+    <p:spTree>
+      <p:nvGrpSpPr>
+        <p:cNvPr id="1" name=""/>
+        <p:cNvGrpSpPr/>
+        <p:nvPr/>
+      </p:nvGrpSpPr>
+      <p:grpSpPr>
+        <a:xfrm>
+          <a:off x="0" y="0"/>
+          <a:ext cx="0" cy="0"/>
+          <a:chOff x="0" y="0"/>
+          <a:chExt cx="0" cy="0"/>
+        </a:xfrm>
+      </p:grpSpPr>
+      <p:sp>
+        <p:nvSpPr>
+          <p:cNvPr id="2" name="Slide Image Placeholder 1"/>
+          <p:cNvSpPr>
+            <a:spLocks noGrp="1" noRot="1" noChangeAspect="1"/>
+          </p:cNvSpPr>
+          <p:nvPr>
+            <p:ph type="sldImg"/>
+          </p:nvPr>
+        </p:nvSpPr>
+        <p:spPr/>
+      </p:sp>
+      <p:sp>
+        <p:nvSpPr>
+          <p:cNvPr id="3" name="Notes Placeholder 2"/>
+          <p:cNvSpPr>
+            <a:spLocks noGrp="1"/>
+          </p:cNvSpPr>
+          <p:nvPr>
+            <p:ph type="body" idx="1"/>
+          </p:nvPr>
+        </p:nvSpPr>
+        <p:spPr/>
+        <p:txBody>
+          <a:bodyPr/>
+          <a:lstStyle/>
+          <a:p>
+            <a:endParaRPr lang="nl-NL" dirty="0"/>
+          </a:p>
+        </p:txBody>
+      </p:sp>
+      <p:sp>
+        <p:nvSpPr>
+          <p:cNvPr id="4" name="Slide Number Placeholder 3"/>
+          <p:cNvSpPr>
+            <a:spLocks noGrp="1"/>
+          </p:cNvSpPr>
+          <p:nvPr>
+            <p:ph type="sldNum" sz="quarter" idx="5"/>
+          </p:nvPr>
+        </p:nvSpPr>
+        <p:spPr/>
+        <p:txBody>
+          <a:bodyPr/>
+          <a:lstStyle/>
+          <a:p>
+            <a:fld id="{5F1F0CA7-94A2-42DA-B20C-BBBE621325FF}" type="slidenum">
+              <a:rPr lang="nl-NL" smtClean="0"/>
+              <a:t>9</a:t>
+            </a:fld>
+            <a:endParaRPr lang="nl-NL"/>
+          </a:p>
+        </p:txBody>
+      </p:sp>
+    </p:spTree>
+    <p:extLst>
+      <p:ext uri="{BB962C8B-B14F-4D97-AF65-F5344CB8AC3E}">
+        <p14:creationId xmlns:p14="http://schemas.microsoft.com/office/powerpoint/2010/main" val="1584562310"/>
+      </p:ext>
+    </p:extLst>
+  </p:cSld>
+  <p:clrMapOvr>
+    <a:masterClrMapping/>
+  </p:clrMapOvr>
+</p:notes>
+</file>
+
 <file path=ppt/slideLayouts/slideLayout1.xml><?xml version="1.0" encoding="utf-8"?>
 <p:sldLayout xmlns:a="http://schemas.openxmlformats.org/drawingml/2006/main" xmlns:r="http://schemas.openxmlformats.org/officeDocument/2006/relationships" xmlns:p="http://schemas.openxmlformats.org/presentationml/2006/main" type="title" preserve="1">
   <p:cSld name="Title Slide">
@@ -4716,7 +4807,7 @@
           <a:p>
             <a:fld id="{A7A69C3B-192C-4ABE-8AD2-9BDA44DCF295}" type="datetimeFigureOut">
               <a:rPr lang="nl-NL" smtClean="0"/>
-              <a:t>24-9-2024</a:t>
+              <a:t>4-10-2024</a:t>
             </a:fld>
             <a:endParaRPr lang="nl-NL"/>
           </a:p>
@@ -4916,7 +5007,7 @@
           <a:p>
             <a:fld id="{A7A69C3B-192C-4ABE-8AD2-9BDA44DCF295}" type="datetimeFigureOut">
               <a:rPr lang="nl-NL" smtClean="0"/>
-              <a:t>24-9-2024</a:t>
+              <a:t>4-10-2024</a:t>
             </a:fld>
             <a:endParaRPr lang="nl-NL"/>
           </a:p>
@@ -5126,7 +5217,7 @@
           <a:p>
             <a:fld id="{A7A69C3B-192C-4ABE-8AD2-9BDA44DCF295}" type="datetimeFigureOut">
               <a:rPr lang="nl-NL" smtClean="0"/>
-              <a:t>24-9-2024</a:t>
+              <a:t>4-10-2024</a:t>
             </a:fld>
             <a:endParaRPr lang="nl-NL"/>
           </a:p>
@@ -5326,7 +5417,7 @@
           <a:p>
             <a:fld id="{A7A69C3B-192C-4ABE-8AD2-9BDA44DCF295}" type="datetimeFigureOut">
               <a:rPr lang="nl-NL" smtClean="0"/>
-              <a:t>24-9-2024</a:t>
+              <a:t>4-10-2024</a:t>
             </a:fld>
             <a:endParaRPr lang="nl-NL"/>
           </a:p>
@@ -5602,7 +5693,7 @@
           <a:p>
             <a:fld id="{A7A69C3B-192C-4ABE-8AD2-9BDA44DCF295}" type="datetimeFigureOut">
               <a:rPr lang="nl-NL" smtClean="0"/>
-              <a:t>24-9-2024</a:t>
+              <a:t>4-10-2024</a:t>
             </a:fld>
             <a:endParaRPr lang="nl-NL"/>
           </a:p>
@@ -5870,7 +5961,7 @@
           <a:p>
             <a:fld id="{A7A69C3B-192C-4ABE-8AD2-9BDA44DCF295}" type="datetimeFigureOut">
               <a:rPr lang="nl-NL" smtClean="0"/>
-              <a:t>24-9-2024</a:t>
+              <a:t>4-10-2024</a:t>
             </a:fld>
             <a:endParaRPr lang="nl-NL"/>
           </a:p>
@@ -6285,7 +6376,7 @@
           <a:p>
             <a:fld id="{A7A69C3B-192C-4ABE-8AD2-9BDA44DCF295}" type="datetimeFigureOut">
               <a:rPr lang="nl-NL" smtClean="0"/>
-              <a:t>24-9-2024</a:t>
+              <a:t>4-10-2024</a:t>
             </a:fld>
             <a:endParaRPr lang="nl-NL"/>
           </a:p>
@@ -6427,7 +6518,7 @@
           <a:p>
             <a:fld id="{A7A69C3B-192C-4ABE-8AD2-9BDA44DCF295}" type="datetimeFigureOut">
               <a:rPr lang="nl-NL" smtClean="0"/>
-              <a:t>24-9-2024</a:t>
+              <a:t>4-10-2024</a:t>
             </a:fld>
             <a:endParaRPr lang="nl-NL"/>
           </a:p>
@@ -6540,7 +6631,7 @@
           <a:p>
             <a:fld id="{A7A69C3B-192C-4ABE-8AD2-9BDA44DCF295}" type="datetimeFigureOut">
               <a:rPr lang="nl-NL" smtClean="0"/>
-              <a:t>24-9-2024</a:t>
+              <a:t>4-10-2024</a:t>
             </a:fld>
             <a:endParaRPr lang="nl-NL"/>
           </a:p>
@@ -6853,7 +6944,7 @@
           <a:p>
             <a:fld id="{A7A69C3B-192C-4ABE-8AD2-9BDA44DCF295}" type="datetimeFigureOut">
               <a:rPr lang="nl-NL" smtClean="0"/>
-              <a:t>24-9-2024</a:t>
+              <a:t>4-10-2024</a:t>
             </a:fld>
             <a:endParaRPr lang="nl-NL"/>
           </a:p>
@@ -7142,7 +7233,7 @@
           <a:p>
             <a:fld id="{A7A69C3B-192C-4ABE-8AD2-9BDA44DCF295}" type="datetimeFigureOut">
               <a:rPr lang="nl-NL" smtClean="0"/>
-              <a:t>24-9-2024</a:t>
+              <a:t>4-10-2024</a:t>
             </a:fld>
             <a:endParaRPr lang="nl-NL"/>
           </a:p>
@@ -7385,7 +7476,7 @@
           <a:p>
             <a:fld id="{A7A69C3B-192C-4ABE-8AD2-9BDA44DCF295}" type="datetimeFigureOut">
               <a:rPr lang="nl-NL" smtClean="0"/>
-              <a:t>24-9-2024</a:t>
+              <a:t>4-10-2024</a:t>
             </a:fld>
             <a:endParaRPr lang="nl-NL"/>
           </a:p>
@@ -10857,7 +10948,9 @@
         </p:nvSpPr>
         <p:spPr/>
         <p:txBody>
-          <a:bodyPr/>
+          <a:bodyPr>
+            <a:normAutofit fontScale="92500"/>
+          </a:bodyPr>
           <a:lstStyle/>
           <a:p>
             <a:pPr marL="0" indent="0">
@@ -10971,14 +11064,6 @@
             </a:r>
             <a:r>
               <a:rPr lang="nl-NL" dirty="0"/>
-              <a:t> </a:t>
-            </a:r>
-            <a:r>
-              <a:rPr lang="nl-NL" dirty="0" err="1"/>
-              <a:t>there</a:t>
-            </a:r>
-            <a:r>
-              <a:rPr lang="nl-NL" dirty="0"/>
               <a:t> a </a:t>
             </a:r>
             <a:r>
@@ -10998,6 +11083,10 @@
                 <a:latin typeface="Consolas" panose="020B0609020204030204" pitchFamily="49" charset="0"/>
               </a:rPr>
               <a:t> </a:t>
+            </a:r>
+            <a:r>
+              <a:rPr lang="nl-NL" dirty="0"/>
+              <a:t>is </a:t>
             </a:r>
             <a:r>
               <a:rPr lang="nl-NL" dirty="0" err="1"/>
@@ -11158,6 +11247,20 @@
               <a:buNone/>
             </a:pPr>
             <a:r>
+              <a:rPr lang="pt-BR" sz="2400" dirty="0">
+                <a:solidFill>
+                  <a:srgbClr val="CCCCCC"/>
+                </a:solidFill>
+                <a:latin typeface="Consolas" panose="020B0609020204030204" pitchFamily="49" charset="0"/>
+              </a:rPr>
+              <a:t>     .. Or explicit in svconfig.ini</a:t>
+            </a:r>
+          </a:p>
+          <a:p>
+            <a:pPr marL="0" indent="0">
+              <a:buNone/>
+            </a:pPr>
+            <a:r>
               <a:rPr lang="nl-NL" sz="2400" dirty="0" err="1">
                 <a:solidFill>
                   <a:srgbClr val="569CD6"/>
@@ -11182,7 +11285,7 @@
                 </a:solidFill>
                 <a:latin typeface="Consolas" panose="020B0609020204030204" pitchFamily="49" charset="0"/>
               </a:rPr>
-              <a:t>trip.ini:repositorybanner</a:t>
+              <a:t>trip.ini:trip_banner</a:t>
             </a:r>
             <a:endParaRPr lang="nl-NL" sz="2400" dirty="0">
               <a:solidFill>
@@ -11190,6 +11293,132 @@
               </a:solidFill>
               <a:latin typeface="Consolas" panose="020B0609020204030204" pitchFamily="49" charset="0"/>
             </a:endParaRPr>
+          </a:p>
+          <a:p>
+            <a:pPr marL="0" indent="0">
+              <a:buNone/>
+            </a:pPr>
+            <a:r>
+              <a:rPr lang="pt-BR" sz="2400" dirty="0">
+                <a:solidFill>
+                  <a:srgbClr val="CCCCCC"/>
+                </a:solidFill>
+                <a:latin typeface="Consolas" panose="020B0609020204030204" pitchFamily="49" charset="0"/>
+              </a:rPr>
+              <a:t>      .. Or “hardcoded” in installation section</a:t>
+            </a:r>
+          </a:p>
+          <a:p>
+            <a:pPr marL="0" indent="0">
+              <a:buNone/>
+            </a:pPr>
+            <a:r>
+              <a:rPr lang="nl-NL" sz="2400" dirty="0" err="1">
+                <a:solidFill>
+                  <a:srgbClr val="569CD6"/>
+                </a:solidFill>
+                <a:latin typeface="Consolas" panose="020B0609020204030204" pitchFamily="49" charset="0"/>
+              </a:rPr>
+              <a:t>RepositoryPicture</a:t>
+            </a:r>
+            <a:r>
+              <a:rPr lang="nl-NL" sz="2400" dirty="0">
+                <a:solidFill>
+                  <a:srgbClr val="569CD6"/>
+                </a:solidFill>
+                <a:latin typeface="Consolas" panose="020B0609020204030204" pitchFamily="49" charset="0"/>
+              </a:rPr>
+              <a:t> = </a:t>
+            </a:r>
+            <a:r>
+              <a:rPr lang="nl-NL" sz="2400" dirty="0" err="1">
+                <a:solidFill>
+                  <a:srgbClr val="569CD6"/>
+                </a:solidFill>
+                <a:latin typeface="Consolas" panose="020B0609020204030204" pitchFamily="49" charset="0"/>
+              </a:rPr>
+              <a:t>trip.ini:trip_picture</a:t>
+            </a:r>
+            <a:r>
+              <a:rPr lang="nl-NL" sz="2400" dirty="0">
+                <a:solidFill>
+                  <a:srgbClr val="569CD6"/>
+                </a:solidFill>
+                <a:latin typeface="Consolas" panose="020B0609020204030204" pitchFamily="49" charset="0"/>
+              </a:rPr>
+              <a:t> </a:t>
+            </a:r>
+            <a:br>
+              <a:rPr lang="nl-NL" sz="2400" dirty="0">
+                <a:solidFill>
+                  <a:srgbClr val="569CD6"/>
+                </a:solidFill>
+                <a:latin typeface="Consolas" panose="020B0609020204030204" pitchFamily="49" charset="0"/>
+              </a:rPr>
+            </a:br>
+            <a:r>
+              <a:rPr lang="nl-NL" sz="2400" dirty="0">
+                <a:solidFill>
+                  <a:srgbClr val="569CD6"/>
+                </a:solidFill>
+                <a:latin typeface="Consolas" panose="020B0609020204030204" pitchFamily="49" charset="0"/>
+              </a:rPr>
+              <a:t>                    (</a:t>
+            </a:r>
+            <a:r>
+              <a:rPr lang="nl-NL" sz="2400" dirty="0" err="1">
+                <a:solidFill>
+                  <a:srgbClr val="569CD6"/>
+                </a:solidFill>
+                <a:latin typeface="Consolas" panose="020B0609020204030204" pitchFamily="49" charset="0"/>
+              </a:rPr>
+              <a:t>path</a:t>
+            </a:r>
+            <a:r>
+              <a:rPr lang="nl-NL" sz="2400" dirty="0">
+                <a:solidFill>
+                  <a:srgbClr val="569CD6"/>
+                </a:solidFill>
+                <a:latin typeface="Consolas" panose="020B0609020204030204" pitchFamily="49" charset="0"/>
+              </a:rPr>
+              <a:t> </a:t>
+            </a:r>
+            <a:r>
+              <a:rPr lang="nl-NL" sz="2400" dirty="0" err="1">
+                <a:solidFill>
+                  <a:srgbClr val="569CD6"/>
+                </a:solidFill>
+                <a:latin typeface="Consolas" panose="020B0609020204030204" pitchFamily="49" charset="0"/>
+              </a:rPr>
+              <a:t>relative</a:t>
+            </a:r>
+            <a:r>
+              <a:rPr lang="nl-NL" sz="2400" dirty="0">
+                <a:solidFill>
+                  <a:srgbClr val="569CD6"/>
+                </a:solidFill>
+                <a:latin typeface="Consolas" panose="020B0609020204030204" pitchFamily="49" charset="0"/>
+              </a:rPr>
+              <a:t> </a:t>
+            </a:r>
+            <a:r>
+              <a:rPr lang="nl-NL" sz="2400" dirty="0" err="1">
+                <a:solidFill>
+                  <a:srgbClr val="569CD6"/>
+                </a:solidFill>
+                <a:latin typeface="Consolas" panose="020B0609020204030204" pitchFamily="49" charset="0"/>
+              </a:rPr>
+              <a:t>to</a:t>
+            </a:r>
+            <a:r>
+              <a:rPr lang="nl-NL" sz="2400" dirty="0">
+                <a:solidFill>
+                  <a:srgbClr val="569CD6"/>
+                </a:solidFill>
+                <a:latin typeface="Consolas" panose="020B0609020204030204" pitchFamily="49" charset="0"/>
+              </a:rPr>
+              <a:t> web/)</a:t>
+            </a:r>
           </a:p>
           <a:p>
             <a:pPr marL="0" indent="0">
@@ -11231,6 +11460,946 @@
     <p:extLst>
       <p:ext uri="{BB962C8B-B14F-4D97-AF65-F5344CB8AC3E}">
         <p14:creationId xmlns:p14="http://schemas.microsoft.com/office/powerpoint/2010/main" val="371199090"/>
+      </p:ext>
+    </p:extLst>
+  </p:cSld>
+  <p:clrMapOvr>
+    <a:masterClrMapping/>
+  </p:clrMapOvr>
+</p:sld>
+</file>
+
+<file path=ppt/slides/slide8.xml><?xml version="1.0" encoding="utf-8"?>
+<p:sld xmlns:a="http://schemas.openxmlformats.org/drawingml/2006/main" xmlns:r="http://schemas.openxmlformats.org/officeDocument/2006/relationships" xmlns:p="http://schemas.openxmlformats.org/presentationml/2006/main">
+  <p:cSld>
+    <p:spTree>
+      <p:nvGrpSpPr>
+        <p:cNvPr id="1" name=""/>
+        <p:cNvGrpSpPr/>
+        <p:nvPr/>
+      </p:nvGrpSpPr>
+      <p:grpSpPr>
+        <a:xfrm>
+          <a:off x="0" y="0"/>
+          <a:ext cx="0" cy="0"/>
+          <a:chOff x="0" y="0"/>
+          <a:chExt cx="0" cy="0"/>
+        </a:xfrm>
+      </p:grpSpPr>
+      <p:sp>
+        <p:nvSpPr>
+          <p:cNvPr id="2" name="Title 1">
+            <a:extLst>
+              <a:ext uri="{FF2B5EF4-FFF2-40B4-BE49-F238E27FC236}">
+                <a16:creationId xmlns:a16="http://schemas.microsoft.com/office/drawing/2014/main" id="{F9A6DE58-BFB7-6B9C-6640-8EF1CEC4419C}"/>
+              </a:ext>
+            </a:extLst>
+          </p:cNvPr>
+          <p:cNvSpPr>
+            <a:spLocks noGrp="1"/>
+          </p:cNvSpPr>
+          <p:nvPr>
+            <p:ph type="title"/>
+          </p:nvPr>
+        </p:nvSpPr>
+        <p:spPr/>
+        <p:txBody>
+          <a:bodyPr/>
+          <a:lstStyle/>
+          <a:p>
+            <a:r>
+              <a:rPr lang="en-GB" dirty="0"/>
+              <a:t>sv1MakeRepository</a:t>
+            </a:r>
+            <a:endParaRPr lang="nl-NL" dirty="0"/>
+          </a:p>
+        </p:txBody>
+      </p:sp>
+      <p:sp>
+        <p:nvSpPr>
+          <p:cNvPr id="3" name="Content Placeholder 2">
+            <a:extLst>
+              <a:ext uri="{FF2B5EF4-FFF2-40B4-BE49-F238E27FC236}">
+                <a16:creationId xmlns:a16="http://schemas.microsoft.com/office/drawing/2014/main" id="{B0567915-AB88-259F-6AB9-32F3C3DAD948}"/>
+              </a:ext>
+            </a:extLst>
+          </p:cNvPr>
+          <p:cNvSpPr>
+            <a:spLocks noGrp="1"/>
+          </p:cNvSpPr>
+          <p:nvPr>
+            <p:ph idx="1"/>
+          </p:nvPr>
+        </p:nvSpPr>
+        <p:spPr/>
+        <p:txBody>
+          <a:bodyPr>
+            <a:normAutofit/>
+          </a:bodyPr>
+          <a:lstStyle/>
+          <a:p>
+            <a:pPr marL="0" indent="0">
+              <a:buNone/>
+            </a:pPr>
+            <a:r>
+              <a:rPr lang="en-GB" dirty="0"/>
+              <a:t>Create a new repository with standard directory and FTP structures</a:t>
+            </a:r>
+          </a:p>
+          <a:p>
+            <a:pPr marL="0" indent="0">
+              <a:buNone/>
+            </a:pPr>
+            <a:r>
+              <a:rPr lang="en-GB" dirty="0"/>
+              <a:t>Pre-</a:t>
+            </a:r>
+            <a:r>
+              <a:rPr lang="en-GB" dirty="0" err="1"/>
+              <a:t>reqs</a:t>
+            </a:r>
+            <a:r>
+              <a:rPr lang="en-GB" dirty="0"/>
+              <a:t>:</a:t>
+            </a:r>
+          </a:p>
+          <a:p>
+            <a:r>
+              <a:rPr lang="en-GB" dirty="0"/>
+              <a:t>svconfig.ini required</a:t>
+            </a:r>
+          </a:p>
+          <a:p>
+            <a:r>
+              <a:rPr lang="en-GB" dirty="0"/>
+              <a:t>Directory best made with trip.ini file in the root</a:t>
+            </a:r>
+          </a:p>
+          <a:p>
+            <a:endParaRPr lang="en-GB" dirty="0"/>
+          </a:p>
+          <a:p>
+            <a:pPr marL="0" indent="0">
+              <a:buNone/>
+            </a:pPr>
+            <a:endParaRPr lang="en-GB" dirty="0"/>
+          </a:p>
+          <a:p>
+            <a:endParaRPr lang="en-GB" dirty="0"/>
+          </a:p>
+          <a:p>
+            <a:endParaRPr lang="nl-NL" dirty="0"/>
+          </a:p>
+        </p:txBody>
+      </p:sp>
+    </p:spTree>
+    <p:extLst>
+      <p:ext uri="{BB962C8B-B14F-4D97-AF65-F5344CB8AC3E}">
+        <p14:creationId xmlns:p14="http://schemas.microsoft.com/office/powerpoint/2010/main" val="1443893975"/>
+      </p:ext>
+    </p:extLst>
+  </p:cSld>
+  <p:clrMapOvr>
+    <a:masterClrMapping/>
+  </p:clrMapOvr>
+</p:sld>
+</file>
+
+<file path=ppt/slides/slide9.xml><?xml version="1.0" encoding="utf-8"?>
+<p:sld xmlns:a="http://schemas.openxmlformats.org/drawingml/2006/main" xmlns:r="http://schemas.openxmlformats.org/officeDocument/2006/relationships" xmlns:p="http://schemas.openxmlformats.org/presentationml/2006/main">
+  <p:cSld>
+    <p:spTree>
+      <p:nvGrpSpPr>
+        <p:cNvPr id="1" name=""/>
+        <p:cNvGrpSpPr/>
+        <p:nvPr/>
+      </p:nvGrpSpPr>
+      <p:grpSpPr>
+        <a:xfrm>
+          <a:off x="0" y="0"/>
+          <a:ext cx="0" cy="0"/>
+          <a:chOff x="0" y="0"/>
+          <a:chExt cx="0" cy="0"/>
+        </a:xfrm>
+      </p:grpSpPr>
+      <p:graphicFrame>
+        <p:nvGraphicFramePr>
+          <p:cNvPr id="4" name="Content Placeholder 3">
+            <a:extLst>
+              <a:ext uri="{FF2B5EF4-FFF2-40B4-BE49-F238E27FC236}">
+                <a16:creationId xmlns:a16="http://schemas.microsoft.com/office/drawing/2014/main" id="{C0E71C7F-F767-0336-6436-4FECD5351309}"/>
+              </a:ext>
+            </a:extLst>
+          </p:cNvPr>
+          <p:cNvGraphicFramePr>
+            <a:graphicFrameLocks noGrp="1"/>
+          </p:cNvGraphicFramePr>
+          <p:nvPr>
+            <p:ph idx="1"/>
+            <p:extLst>
+              <p:ext uri="{D42A27DB-BD31-4B8C-83A1-F6EECF244321}">
+                <p14:modId xmlns:p14="http://schemas.microsoft.com/office/powerpoint/2010/main" val="2296702942"/>
+              </p:ext>
+            </p:extLst>
+          </p:nvPr>
+        </p:nvGraphicFramePr>
+        <p:xfrm>
+          <a:off x="617220" y="992108"/>
+          <a:ext cx="11064240" cy="5496560"/>
+        </p:xfrm>
+        <a:graphic>
+          <a:graphicData uri="http://schemas.openxmlformats.org/drawingml/2006/table">
+            <a:tbl>
+              <a:tblPr firstRow="1" bandRow="1">
+                <a:tableStyleId>{5C22544A-7EE6-4342-B048-85BDC9FD1C3A}</a:tableStyleId>
+              </a:tblPr>
+              <a:tblGrid>
+                <a:gridCol w="3139440">
+                  <a:extLst>
+                    <a:ext uri="{9D8B030D-6E8A-4147-A177-3AD203B41FA5}">
+                      <a16:colId xmlns:a16="http://schemas.microsoft.com/office/drawing/2014/main" val="2840247616"/>
+                    </a:ext>
+                  </a:extLst>
+                </a:gridCol>
+                <a:gridCol w="1036320">
+                  <a:extLst>
+                    <a:ext uri="{9D8B030D-6E8A-4147-A177-3AD203B41FA5}">
+                      <a16:colId xmlns:a16="http://schemas.microsoft.com/office/drawing/2014/main" val="3158828686"/>
+                    </a:ext>
+                  </a:extLst>
+                </a:gridCol>
+                <a:gridCol w="1036320">
+                  <a:extLst>
+                    <a:ext uri="{9D8B030D-6E8A-4147-A177-3AD203B41FA5}">
+                      <a16:colId xmlns:a16="http://schemas.microsoft.com/office/drawing/2014/main" val="3723561695"/>
+                    </a:ext>
+                  </a:extLst>
+                </a:gridCol>
+                <a:gridCol w="5852160">
+                  <a:extLst>
+                    <a:ext uri="{9D8B030D-6E8A-4147-A177-3AD203B41FA5}">
+                      <a16:colId xmlns:a16="http://schemas.microsoft.com/office/drawing/2014/main" val="3936547858"/>
+                    </a:ext>
+                  </a:extLst>
+                </a:gridCol>
+              </a:tblGrid>
+              <a:tr h="370840">
+                <a:tc>
+                  <a:txBody>
+                    <a:bodyPr/>
+                    <a:lstStyle/>
+                    <a:p>
+                      <a:r>
+                        <a:rPr lang="en-GB" dirty="0"/>
+                        <a:t>Utility</a:t>
+                      </a:r>
+                      <a:endParaRPr lang="nl-NL" dirty="0"/>
+                    </a:p>
+                  </a:txBody>
+                  <a:tcPr/>
+                </a:tc>
+                <a:tc>
+                  <a:txBody>
+                    <a:bodyPr/>
+                    <a:lstStyle/>
+                    <a:p>
+                      <a:r>
+                        <a:rPr lang="en-GB" dirty="0"/>
+                        <a:t>Works on </a:t>
+                      </a:r>
+                      <a:r>
+                        <a:rPr lang="en-GB" dirty="0" err="1"/>
+                        <a:t>ini</a:t>
+                      </a:r>
+                      <a:endParaRPr lang="nl-NL" dirty="0"/>
+                    </a:p>
+                  </a:txBody>
+                  <a:tcPr/>
+                </a:tc>
+                <a:tc>
+                  <a:txBody>
+                    <a:bodyPr/>
+                    <a:lstStyle/>
+                    <a:p>
+                      <a:r>
+                        <a:rPr lang="en-GB" dirty="0"/>
+                        <a:t>Needs edits?*</a:t>
+                      </a:r>
+                      <a:endParaRPr lang="nl-NL" dirty="0"/>
+                    </a:p>
+                  </a:txBody>
+                  <a:tcPr/>
+                </a:tc>
+                <a:tc>
+                  <a:txBody>
+                    <a:bodyPr/>
+                    <a:lstStyle/>
+                    <a:p>
+                      <a:r>
+                        <a:rPr lang="en-GB" dirty="0"/>
+                        <a:t>Purpose</a:t>
+                      </a:r>
+                      <a:endParaRPr lang="nl-NL" dirty="0"/>
+                    </a:p>
+                  </a:txBody>
+                  <a:tcPr/>
+                </a:tc>
+                <a:extLst>
+                  <a:ext uri="{0D108BD9-81ED-4DB2-BD59-A6C34878D82A}">
+                    <a16:rowId xmlns:a16="http://schemas.microsoft.com/office/drawing/2014/main" val="2249949909"/>
+                  </a:ext>
+                </a:extLst>
+              </a:tr>
+              <a:tr h="370840">
+                <a:tc>
+                  <a:txBody>
+                    <a:bodyPr/>
+                    <a:lstStyle/>
+                    <a:p>
+                      <a:r>
+                        <a:rPr lang="en-GB" dirty="0"/>
+                        <a:t>svr1AddSpecies</a:t>
+                      </a:r>
+                      <a:endParaRPr lang="nl-NL" dirty="0"/>
+                    </a:p>
+                  </a:txBody>
+                  <a:tcPr/>
+                </a:tc>
+                <a:tc>
+                  <a:txBody>
+                    <a:bodyPr/>
+                    <a:lstStyle/>
+                    <a:p>
+                      <a:r>
+                        <a:rPr lang="en-GB" dirty="0"/>
+                        <a:t>Both</a:t>
+                      </a:r>
+                      <a:endParaRPr lang="nl-NL" dirty="0"/>
+                    </a:p>
+                  </a:txBody>
+                  <a:tcPr/>
+                </a:tc>
+                <a:tc>
+                  <a:txBody>
+                    <a:bodyPr/>
+                    <a:lstStyle/>
+                    <a:p>
+                      <a:r>
+                        <a:rPr lang="en-GB" dirty="0"/>
+                        <a:t>No</a:t>
+                      </a:r>
+                      <a:endParaRPr lang="nl-NL" dirty="0"/>
+                    </a:p>
+                  </a:txBody>
+                  <a:tcPr/>
+                </a:tc>
+                <a:tc>
+                  <a:txBody>
+                    <a:bodyPr/>
+                    <a:lstStyle/>
+                    <a:p>
+                      <a:pPr marL="0" marR="0" lvl="0" indent="0" algn="l" defTabSz="914400" rtl="0" eaLnBrk="1" fontAlgn="auto" latinLnBrk="0" hangingPunct="1">
+                        <a:lnSpc>
+                          <a:spcPct val="100000"/>
+                        </a:lnSpc>
+                        <a:spcBef>
+                          <a:spcPts val="0"/>
+                        </a:spcBef>
+                        <a:spcAft>
+                          <a:spcPts val="0"/>
+                        </a:spcAft>
+                        <a:buClrTx/>
+                        <a:buSzTx/>
+                        <a:buFontTx/>
+                        <a:buNone/>
+                        <a:tabLst/>
+                        <a:defRPr/>
+                      </a:pPr>
+                      <a:r>
+                        <a:rPr lang="en-GB" dirty="0"/>
+                        <a:t>Helper.  Add species to </a:t>
+                      </a:r>
+                      <a:r>
+                        <a:rPr lang="nl-NL" sz="1800" b="0" kern="1200" dirty="0">
+                          <a:solidFill>
+                            <a:schemeClr val="dk1"/>
+                          </a:solidFill>
+                          <a:effectLst/>
+                          <a:latin typeface="+mn-lt"/>
+                          <a:ea typeface="+mn-ea"/>
+                          <a:cs typeface="+mn-cs"/>
+                        </a:rPr>
+                        <a:t>speciescollection.csv </a:t>
+                      </a:r>
+                      <a:r>
+                        <a:rPr lang="nl-NL" sz="1800" b="0" kern="1200" dirty="0" err="1">
+                          <a:solidFill>
+                            <a:schemeClr val="dk1"/>
+                          </a:solidFill>
+                          <a:effectLst/>
+                          <a:latin typeface="+mn-lt"/>
+                          <a:ea typeface="+mn-ea"/>
+                          <a:cs typeface="+mn-cs"/>
+                        </a:rPr>
+                        <a:t>based</a:t>
+                      </a:r>
+                      <a:r>
+                        <a:rPr lang="nl-NL" sz="1800" b="0" kern="1200" dirty="0">
+                          <a:solidFill>
+                            <a:schemeClr val="dk1"/>
+                          </a:solidFill>
+                          <a:effectLst/>
+                          <a:latin typeface="+mn-lt"/>
+                          <a:ea typeface="+mn-ea"/>
+                          <a:cs typeface="+mn-cs"/>
+                        </a:rPr>
+                        <a:t> on list in </a:t>
+                      </a:r>
+                      <a:r>
+                        <a:rPr lang="nl-NL" sz="1800" b="0" kern="1200" dirty="0" err="1">
+                          <a:solidFill>
+                            <a:schemeClr val="dk1"/>
+                          </a:solidFill>
+                          <a:effectLst/>
+                          <a:latin typeface="+mn-lt"/>
+                          <a:ea typeface="+mn-ea"/>
+                          <a:cs typeface="+mn-cs"/>
+                        </a:rPr>
+                        <a:t>admin</a:t>
+                      </a:r>
+                      <a:r>
+                        <a:rPr lang="nl-NL" sz="1800" b="0" kern="1200" dirty="0">
+                          <a:solidFill>
+                            <a:schemeClr val="dk1"/>
+                          </a:solidFill>
+                          <a:effectLst/>
+                          <a:latin typeface="+mn-lt"/>
+                          <a:ea typeface="+mn-ea"/>
+                          <a:cs typeface="+mn-cs"/>
+                        </a:rPr>
+                        <a:t>/speclist.csv</a:t>
+                      </a:r>
+                    </a:p>
+                  </a:txBody>
+                  <a:tcPr/>
+                </a:tc>
+                <a:extLst>
+                  <a:ext uri="{0D108BD9-81ED-4DB2-BD59-A6C34878D82A}">
+                    <a16:rowId xmlns:a16="http://schemas.microsoft.com/office/drawing/2014/main" val="1354462080"/>
+                  </a:ext>
+                </a:extLst>
+              </a:tr>
+              <a:tr h="370840">
+                <a:tc>
+                  <a:txBody>
+                    <a:bodyPr/>
+                    <a:lstStyle/>
+                    <a:p>
+                      <a:r>
+                        <a:rPr lang="en-GB" dirty="0"/>
+                        <a:t>svr2CountSpecies</a:t>
+                      </a:r>
+                      <a:endParaRPr lang="nl-NL" dirty="0"/>
+                    </a:p>
+                  </a:txBody>
+                  <a:tcPr/>
+                </a:tc>
+                <a:tc>
+                  <a:txBody>
+                    <a:bodyPr/>
+                    <a:lstStyle/>
+                    <a:p>
+                      <a:r>
+                        <a:rPr lang="en-GB" dirty="0"/>
+                        <a:t>Trip</a:t>
+                      </a:r>
+                      <a:endParaRPr lang="nl-NL" dirty="0"/>
+                    </a:p>
+                  </a:txBody>
+                  <a:tcPr/>
+                </a:tc>
+                <a:tc>
+                  <a:txBody>
+                    <a:bodyPr/>
+                    <a:lstStyle/>
+                    <a:p>
+                      <a:r>
+                        <a:rPr lang="en-GB" dirty="0"/>
+                        <a:t>No</a:t>
+                      </a:r>
+                      <a:endParaRPr lang="nl-NL" dirty="0"/>
+                    </a:p>
+                  </a:txBody>
+                  <a:tcPr/>
+                </a:tc>
+                <a:tc>
+                  <a:txBody>
+                    <a:bodyPr/>
+                    <a:lstStyle/>
+                    <a:p>
+                      <a:r>
+                        <a:rPr lang="en-GB" dirty="0"/>
+                        <a:t>Stats. Count the number of species that are not yet in master</a:t>
+                      </a:r>
+                      <a:endParaRPr lang="nl-NL" dirty="0"/>
+                    </a:p>
+                  </a:txBody>
+                  <a:tcPr/>
+                </a:tc>
+                <a:extLst>
+                  <a:ext uri="{0D108BD9-81ED-4DB2-BD59-A6C34878D82A}">
+                    <a16:rowId xmlns:a16="http://schemas.microsoft.com/office/drawing/2014/main" val="2019498000"/>
+                  </a:ext>
+                </a:extLst>
+              </a:tr>
+              <a:tr h="370840">
+                <a:tc>
+                  <a:txBody>
+                    <a:bodyPr/>
+                    <a:lstStyle/>
+                    <a:p>
+                      <a:r>
+                        <a:rPr lang="en-GB" dirty="0"/>
+                        <a:t>svr3StatusProjects</a:t>
+                      </a:r>
+                      <a:endParaRPr lang="nl-NL" dirty="0"/>
+                    </a:p>
+                  </a:txBody>
+                  <a:tcPr/>
+                </a:tc>
+                <a:tc>
+                  <a:txBody>
+                    <a:bodyPr/>
+                    <a:lstStyle/>
+                    <a:p>
+                      <a:r>
+                        <a:rPr lang="en-GB" dirty="0"/>
+                        <a:t>Trip</a:t>
+                      </a:r>
+                      <a:endParaRPr lang="nl-NL" dirty="0"/>
+                    </a:p>
+                  </a:txBody>
+                  <a:tcPr/>
+                </a:tc>
+                <a:tc>
+                  <a:txBody>
+                    <a:bodyPr/>
+                    <a:lstStyle/>
+                    <a:p>
+                      <a:r>
+                        <a:rPr lang="en-GB" dirty="0"/>
+                        <a:t>No</a:t>
+                      </a:r>
+                      <a:endParaRPr lang="nl-NL" dirty="0"/>
+                    </a:p>
+                  </a:txBody>
+                  <a:tcPr/>
+                </a:tc>
+                <a:tc>
+                  <a:txBody>
+                    <a:bodyPr/>
+                    <a:lstStyle/>
+                    <a:p>
+                      <a:r>
+                        <a:rPr lang="en-GB" dirty="0"/>
+                        <a:t>Stats. Report project steps that are run for trip</a:t>
+                      </a:r>
+                      <a:endParaRPr lang="nl-NL" dirty="0"/>
+                    </a:p>
+                  </a:txBody>
+                  <a:tcPr/>
+                </a:tc>
+                <a:extLst>
+                  <a:ext uri="{0D108BD9-81ED-4DB2-BD59-A6C34878D82A}">
+                    <a16:rowId xmlns:a16="http://schemas.microsoft.com/office/drawing/2014/main" val="253633987"/>
+                  </a:ext>
+                </a:extLst>
+              </a:tr>
+              <a:tr h="370840">
+                <a:tc>
+                  <a:txBody>
+                    <a:bodyPr/>
+                    <a:lstStyle/>
+                    <a:p>
+                      <a:r>
+                        <a:rPr lang="en-GB" dirty="0"/>
+                        <a:t>svr4UpdateTrips</a:t>
+                      </a:r>
+                      <a:endParaRPr lang="nl-NL" dirty="0"/>
+                    </a:p>
+                  </a:txBody>
+                  <a:tcPr/>
+                </a:tc>
+                <a:tc>
+                  <a:txBody>
+                    <a:bodyPr/>
+                    <a:lstStyle/>
+                    <a:p>
+                      <a:r>
+                        <a:rPr lang="en-GB" dirty="0"/>
+                        <a:t>Trip</a:t>
+                      </a:r>
+                      <a:endParaRPr lang="nl-NL" dirty="0"/>
+                    </a:p>
+                  </a:txBody>
+                  <a:tcPr/>
+                </a:tc>
+                <a:tc>
+                  <a:txBody>
+                    <a:bodyPr/>
+                    <a:lstStyle/>
+                    <a:p>
+                      <a:r>
+                        <a:rPr lang="en-GB" dirty="0"/>
+                        <a:t>trip.ini</a:t>
+                      </a:r>
+                      <a:endParaRPr lang="nl-NL" dirty="0"/>
+                    </a:p>
+                  </a:txBody>
+                  <a:tcPr/>
+                </a:tc>
+                <a:tc>
+                  <a:txBody>
+                    <a:bodyPr/>
+                    <a:lstStyle/>
+                    <a:p>
+                      <a:r>
+                        <a:rPr lang="en-GB" dirty="0"/>
+                        <a:t>Needed for each trip. Update the metadata for trip and update website.  </a:t>
+                      </a:r>
+                      <a:endParaRPr lang="nl-NL" dirty="0"/>
+                    </a:p>
+                  </a:txBody>
+                  <a:tcPr/>
+                </a:tc>
+                <a:extLst>
+                  <a:ext uri="{0D108BD9-81ED-4DB2-BD59-A6C34878D82A}">
+                    <a16:rowId xmlns:a16="http://schemas.microsoft.com/office/drawing/2014/main" val="775449291"/>
+                  </a:ext>
+                </a:extLst>
+              </a:tr>
+              <a:tr h="370840">
+                <a:tc>
+                  <a:txBody>
+                    <a:bodyPr/>
+                    <a:lstStyle/>
+                    <a:p>
+                      <a:r>
+                        <a:rPr lang="nl-NL" dirty="0"/>
+                        <a:t>svr5MergeSpeciesCollections</a:t>
+                      </a:r>
+                    </a:p>
+                  </a:txBody>
+                  <a:tcPr/>
+                </a:tc>
+                <a:tc>
+                  <a:txBody>
+                    <a:bodyPr/>
+                    <a:lstStyle/>
+                    <a:p>
+                      <a:endParaRPr lang="nl-NL"/>
+                    </a:p>
+                  </a:txBody>
+                  <a:tcPr/>
+                </a:tc>
+                <a:tc>
+                  <a:txBody>
+                    <a:bodyPr/>
+                    <a:lstStyle/>
+                    <a:p>
+                      <a:r>
+                        <a:rPr lang="en-GB" dirty="0"/>
+                        <a:t>Yes</a:t>
+                      </a:r>
+                      <a:endParaRPr lang="nl-NL" dirty="0"/>
+                    </a:p>
+                  </a:txBody>
+                  <a:tcPr/>
+                </a:tc>
+                <a:tc>
+                  <a:txBody>
+                    <a:bodyPr/>
+                    <a:lstStyle/>
+                    <a:p>
+                      <a:r>
+                        <a:rPr lang="en-GB" dirty="0"/>
+                        <a:t>Needed for </a:t>
+                      </a:r>
+                      <a:r>
+                        <a:rPr lang="en-GB"/>
+                        <a:t>new English/</a:t>
+                      </a:r>
+                      <a:r>
+                        <a:rPr lang="en-GB" dirty="0"/>
+                        <a:t>Dutch names.  Merge the species from 2 lists, </a:t>
+                      </a:r>
+                      <a:r>
+                        <a:rPr lang="en-GB" dirty="0" err="1"/>
+                        <a:t>eg</a:t>
+                      </a:r>
+                      <a:r>
+                        <a:rPr lang="en-GB" dirty="0"/>
+                        <a:t> master and trip</a:t>
+                      </a:r>
+                      <a:endParaRPr lang="nl-NL" dirty="0"/>
+                    </a:p>
+                  </a:txBody>
+                  <a:tcPr/>
+                </a:tc>
+                <a:extLst>
+                  <a:ext uri="{0D108BD9-81ED-4DB2-BD59-A6C34878D82A}">
+                    <a16:rowId xmlns:a16="http://schemas.microsoft.com/office/drawing/2014/main" val="466339600"/>
+                  </a:ext>
+                </a:extLst>
+              </a:tr>
+              <a:tr h="370840">
+                <a:tc>
+                  <a:txBody>
+                    <a:bodyPr/>
+                    <a:lstStyle/>
+                    <a:p>
+                      <a:r>
+                        <a:rPr lang="nl-NL" dirty="0"/>
+                        <a:t>svr6MergeBlogsForMaster</a:t>
+                      </a:r>
+                    </a:p>
+                  </a:txBody>
+                  <a:tcPr/>
+                </a:tc>
+                <a:tc>
+                  <a:txBody>
+                    <a:bodyPr/>
+                    <a:lstStyle/>
+                    <a:p>
+                      <a:r>
+                        <a:rPr lang="en-GB" dirty="0"/>
+                        <a:t>Master</a:t>
+                      </a:r>
+                      <a:endParaRPr lang="nl-NL" dirty="0"/>
+                    </a:p>
+                  </a:txBody>
+                  <a:tcPr/>
+                </a:tc>
+                <a:tc>
+                  <a:txBody>
+                    <a:bodyPr/>
+                    <a:lstStyle/>
+                    <a:p>
+                      <a:r>
+                        <a:rPr lang="en-GB" dirty="0"/>
+                        <a:t>No</a:t>
+                      </a:r>
+                      <a:endParaRPr lang="nl-NL" dirty="0"/>
+                    </a:p>
+                  </a:txBody>
+                  <a:tcPr/>
+                </a:tc>
+                <a:tc>
+                  <a:txBody>
+                    <a:bodyPr/>
+                    <a:lstStyle/>
+                    <a:p>
+                      <a:r>
+                        <a:rPr lang="en-GB" dirty="0"/>
+                        <a:t>Needs at least once for each trip, blog count update not automatic.  Create a different blog report for master, blogs per trips rather than all blogs</a:t>
+                      </a:r>
+                      <a:endParaRPr lang="nl-NL" dirty="0"/>
+                    </a:p>
+                  </a:txBody>
+                  <a:tcPr/>
+                </a:tc>
+                <a:extLst>
+                  <a:ext uri="{0D108BD9-81ED-4DB2-BD59-A6C34878D82A}">
+                    <a16:rowId xmlns:a16="http://schemas.microsoft.com/office/drawing/2014/main" val="1830438468"/>
+                  </a:ext>
+                </a:extLst>
+              </a:tr>
+              <a:tr h="370840">
+                <a:tc>
+                  <a:txBody>
+                    <a:bodyPr/>
+                    <a:lstStyle/>
+                    <a:p>
+                      <a:r>
+                        <a:rPr lang="en-GB" dirty="0"/>
+                        <a:t>svr7DeleteFiles</a:t>
+                      </a:r>
+                      <a:endParaRPr lang="nl-NL" dirty="0"/>
+                    </a:p>
+                  </a:txBody>
+                  <a:tcPr/>
+                </a:tc>
+                <a:tc>
+                  <a:txBody>
+                    <a:bodyPr/>
+                    <a:lstStyle/>
+                    <a:p>
+                      <a:r>
+                        <a:rPr lang="en-GB" dirty="0"/>
+                        <a:t>Both</a:t>
+                      </a:r>
+                      <a:endParaRPr lang="nl-NL" dirty="0"/>
+                    </a:p>
+                  </a:txBody>
+                  <a:tcPr/>
+                </a:tc>
+                <a:tc>
+                  <a:txBody>
+                    <a:bodyPr/>
+                    <a:lstStyle/>
+                    <a:p>
+                      <a:endParaRPr lang="nl-NL"/>
+                    </a:p>
+                  </a:txBody>
+                  <a:tcPr/>
+                </a:tc>
+                <a:tc>
+                  <a:txBody>
+                    <a:bodyPr/>
+                    <a:lstStyle/>
+                    <a:p>
+                      <a:r>
+                        <a:rPr lang="en-GB" dirty="0"/>
+                        <a:t>Clean duplicate files. (does not yet exist) Delete files that have been copied to master</a:t>
+                      </a:r>
+                      <a:endParaRPr lang="nl-NL" dirty="0"/>
+                    </a:p>
+                  </a:txBody>
+                  <a:tcPr/>
+                </a:tc>
+                <a:extLst>
+                  <a:ext uri="{0D108BD9-81ED-4DB2-BD59-A6C34878D82A}">
+                    <a16:rowId xmlns:a16="http://schemas.microsoft.com/office/drawing/2014/main" val="1080765452"/>
+                  </a:ext>
+                </a:extLst>
+              </a:tr>
+              <a:tr h="370840">
+                <a:tc>
+                  <a:txBody>
+                    <a:bodyPr/>
+                    <a:lstStyle/>
+                    <a:p>
+                      <a:endParaRPr lang="nl-NL" dirty="0"/>
+                    </a:p>
+                  </a:txBody>
+                  <a:tcPr/>
+                </a:tc>
+                <a:tc>
+                  <a:txBody>
+                    <a:bodyPr/>
+                    <a:lstStyle/>
+                    <a:p>
+                      <a:endParaRPr lang="nl-NL" dirty="0"/>
+                    </a:p>
+                  </a:txBody>
+                  <a:tcPr/>
+                </a:tc>
+                <a:tc>
+                  <a:txBody>
+                    <a:bodyPr/>
+                    <a:lstStyle/>
+                    <a:p>
+                      <a:endParaRPr lang="nl-NL"/>
+                    </a:p>
+                  </a:txBody>
+                  <a:tcPr/>
+                </a:tc>
+                <a:tc>
+                  <a:txBody>
+                    <a:bodyPr/>
+                    <a:lstStyle/>
+                    <a:p>
+                      <a:endParaRPr lang="nl-NL" dirty="0"/>
+                    </a:p>
+                  </a:txBody>
+                  <a:tcPr/>
+                </a:tc>
+                <a:extLst>
+                  <a:ext uri="{0D108BD9-81ED-4DB2-BD59-A6C34878D82A}">
+                    <a16:rowId xmlns:a16="http://schemas.microsoft.com/office/drawing/2014/main" val="3096990806"/>
+                  </a:ext>
+                </a:extLst>
+              </a:tr>
+            </a:tbl>
+          </a:graphicData>
+        </a:graphic>
+      </p:graphicFrame>
+      <p:sp>
+        <p:nvSpPr>
+          <p:cNvPr id="5" name="TextBox 4">
+            <a:extLst>
+              <a:ext uri="{FF2B5EF4-FFF2-40B4-BE49-F238E27FC236}">
+                <a16:creationId xmlns:a16="http://schemas.microsoft.com/office/drawing/2014/main" id="{ABBCF386-00BA-C3FC-2471-8972B85A1A8E}"/>
+              </a:ext>
+            </a:extLst>
+          </p:cNvPr>
+          <p:cNvSpPr txBox="1"/>
+          <p:nvPr/>
+        </p:nvSpPr>
+        <p:spPr>
+          <a:xfrm>
+            <a:off x="510540" y="6488668"/>
+            <a:ext cx="11064240" cy="369332"/>
+          </a:xfrm>
+          <a:prstGeom prst="rect">
+            <a:avLst/>
+          </a:prstGeom>
+          <a:noFill/>
+        </p:spPr>
+        <p:txBody>
+          <a:bodyPr wrap="square" rtlCol="0">
+            <a:spAutoFit/>
+          </a:bodyPr>
+          <a:lstStyle/>
+          <a:p>
+            <a:r>
+              <a:rPr lang="en-GB" dirty="0"/>
+              <a:t>* /trips/ is fixed and assumed to the high level directory for trips, that are second level directories</a:t>
+            </a:r>
+            <a:endParaRPr lang="nl-NL" dirty="0"/>
+          </a:p>
+        </p:txBody>
+      </p:sp>
+      <p:sp>
+        <p:nvSpPr>
+          <p:cNvPr id="7" name="Title 6">
+            <a:extLst>
+              <a:ext uri="{FF2B5EF4-FFF2-40B4-BE49-F238E27FC236}">
+                <a16:creationId xmlns:a16="http://schemas.microsoft.com/office/drawing/2014/main" id="{5C2D0917-B20E-3BD3-E915-1DB1A543ECBD}"/>
+              </a:ext>
+            </a:extLst>
+          </p:cNvPr>
+          <p:cNvSpPr>
+            <a:spLocks noGrp="1"/>
+          </p:cNvSpPr>
+          <p:nvPr>
+            <p:ph type="title"/>
+          </p:nvPr>
+        </p:nvSpPr>
+        <p:spPr>
+          <a:xfrm>
+            <a:off x="617220" y="182245"/>
+            <a:ext cx="10515600" cy="686435"/>
+          </a:xfrm>
+        </p:spPr>
+        <p:txBody>
+          <a:bodyPr>
+            <a:normAutofit fontScale="90000"/>
+          </a:bodyPr>
+          <a:lstStyle/>
+          <a:p>
+            <a:r>
+              <a:rPr lang="en-GB" dirty="0"/>
+              <a:t>Utilities</a:t>
+            </a:r>
+            <a:endParaRPr lang="nl-NL" dirty="0"/>
+          </a:p>
+        </p:txBody>
+      </p:sp>
+    </p:spTree>
+    <p:extLst>
+      <p:ext uri="{BB962C8B-B14F-4D97-AF65-F5344CB8AC3E}">
+        <p14:creationId xmlns:p14="http://schemas.microsoft.com/office/powerpoint/2010/main" val="4112590493"/>
       </p:ext>
     </p:extLst>
   </p:cSld>

</xml_diff>